<commit_message>
Align doc collateral to canonical facts + regenerate
- build_ueba_whitepaper / build_implementation_spec / build_bei_concept_paper:
  8.5%->8.1% FP, "magnitude AND direction" (not direction-instead-of), composite
  4/4 @ 8.1% (cleanly separates 2/4) + Threat-Profile 4/4 @ 0 FP framing.
- Regenerate the .docx/.pptx outputs from the corrected builders.
- APP_REFERENCE.md: add section 9 (doc-collateral canonical rules + the
  50-user/19-week study exception in the Whitepapers analysis docs).

Co-Authored-By: Claude Opus 4.8 (1M context) <noreply@anthropic.com>
</commit_message>
<xml_diff>
--- a/docs/Detection_Comparison_Business_Deck.pptx
+++ b/docs/Detection_Comparison_Business_Deck.pptx
@@ -3377,7 +3377,7 @@
               </a:defRPr>
             </a:pPr>
             <a:r>
-              <a:t>Deep Dive: How Composite Scoring Catches a 180-Day APT</a:t>
+              <a:t>Deep Dive: How the Threat-Profile Detector Catches a 180-Day APT</a:t>
             </a:r>
           </a:p>
         </p:txBody>
@@ -3456,7 +3456,7 @@
               </a:defRPr>
             </a:pPr>
             <a:r>
-              <a:t>USR-234 is the hardest attacker to detect. Every traditional metric looks normal. Even basic behavioral drift analysis barely separates this user from the crowd.</a:t>
+              <a:t>USR-234 is the hardest attacker to detect. Every traditional metric looks normal, and even the composite score ranks it below the normal population — drift magnitude alone is not enough.</a:t>
             </a:r>
           </a:p>
         </p:txBody>
@@ -3880,7 +3880,7 @@
               </a:defRPr>
             </a:pPr>
             <a:r>
-              <a:t>What Composite Scoring Sees</a:t>
+              <a:t>What the Threat-Profile Detector Sees</a:t>
             </a:r>
           </a:p>
         </p:txBody>
@@ -3952,7 +3952,7 @@
               </a:defRPr>
             </a:pPr>
             <a:r>
-              <a:t>Low (14th percentile) — drift magnitude is small</a:t>
+              <a:t>Low — drift magnitude is small (composite ranks below normal)</a:t>
             </a:r>
           </a:p>
         </p:txBody>
@@ -4024,7 +4024,7 @@
               </a:defRPr>
             </a:pPr>
             <a:r>
-              <a:t>Low (5th percentile) — only 1 feature mildly anomalous</a:t>
+              <a:t>Low — only 1 feature mildly anomalous</a:t>
             </a:r>
           </a:p>
         </p:txBody>
@@ -4096,7 +4096,7 @@
               </a:defRPr>
             </a:pPr>
             <a:r>
-              <a:t>Low (31st percentile) — not persistently high</a:t>
+              <a:t>Low — not persistently high in raw magnitude</a:t>
             </a:r>
           </a:p>
         </p:txBody>
@@ -4168,7 +4168,7 @@
               </a:defRPr>
             </a:pPr>
             <a:r>
-              <a:t>Moderate (29th percentile) — starting to show</a:t>
+              <a:t>Moderate — starting to show</a:t>
             </a:r>
           </a:p>
         </p:txBody>
@@ -4204,7 +4204,7 @@
               </a:defRPr>
             </a:pPr>
             <a:r>
-              <a:t>  Novelty Persistence:</a:t>
+              <a:t>  C2-beacon profile:</a:t>
             </a:r>
           </a:p>
         </p:txBody>
@@ -4240,7 +4240,7 @@
               </a:defRPr>
             </a:pPr>
             <a:r>
-              <a:t>MAXIMUM (100th percentile) — novel network destinations persist every week</a:t>
+              <a:t>MATCH — novel destinations recur with beacon-like cadence</a:t>
             </a:r>
           </a:p>
         </p:txBody>
@@ -4429,7 +4429,7 @@
               </a:defRPr>
             </a:pPr>
             <a:r>
-              <a:t>USR-234's network volume, byte counts, and connection rates all look normal. But the destinations are new, and they persist. Composite Scoring's Novelty Persistence phase catches exactly this pattern — ranking USR-234 at #7 out of 250 users despite every other metric looking clean.</a:t>
+              <a:t>USR-234's network volume, byte counts, and connection rates all look normal — so normal that the composite score ranks it below the average user. But the destinations are new, and they recur with beacon-like cadence. The threat-profile detector's C2-beacon front matches exactly this pattern, catching USR-234 with zero false positives where magnitude-based scoring cannot.</a:t>
             </a:r>
           </a:p>
         </p:txBody>
@@ -7223,7 +7223,7 @@
               </a:defRPr>
             </a:pPr>
             <a:r>
-              <a:t>V-Intelligence UEBA + Composite</a:t>
+              <a:t>V-Intelligence Threat-Profile</a:t>
             </a:r>
           </a:p>
         </p:txBody>
@@ -7331,7 +7331,7 @@
               </a:defRPr>
             </a:pPr>
             <a:r>
-              <a:t>FP Rate: 8.5%</a:t>
+              <a:t>FP Rate: 0%</a:t>
             </a:r>
           </a:p>
         </p:txBody>
@@ -7367,7 +7367,7 @@
               </a:defRPr>
             </a:pPr>
             <a:r>
-              <a:t>Catches ALL attackers, manageable FP</a:t>
+              <a:t>Catches ALL attackers, no false alarms</a:t>
             </a:r>
           </a:p>
         </p:txBody>
@@ -7448,7 +7448,7 @@
               </a:defRPr>
             </a:pPr>
             <a:r>
-              <a:t>What does 8.5% FP rate mean in practice?</a:t>
+              <a:t>What does a 0% FP rate mean in practice?</a:t>
             </a:r>
           </a:p>
         </p:txBody>
@@ -7484,7 +7484,7 @@
               </a:defRPr>
             </a:pPr>
             <a:r>
-              <a:t>In an organization with 10,000 users, 8.5% FP = ~850 users flagged for review. With composite scoring's ranked list, analysts start at #1 (highest risk) and work down — all 4 real attackers appear in the top 10%. Compare this to Z-Score which catches 1 attacker buried among 980 false alarms with no ranking.</a:t>
+              <a:t>In an organization with 10,000 users, the threat-profile detector returns only confirmed profile matches — no broad sweep of users to triage. All 4 real attackers surface with zero false positives. Compare this to Z-Score which catches 1 attacker buried among 980 false alarms with no ranking.</a:t>
             </a:r>
           </a:p>
         </p:txBody>
@@ -7856,7 +7856,7 @@
               </a:defRPr>
             </a:pPr>
             <a:r>
-              <a:t>  4 of 4 attack types detected in testing</a:t>
+              <a:t>  4 of 4 attack types detected — threat-profile detector</a:t>
             </a:r>
           </a:p>
         </p:txBody>
@@ -8014,7 +8014,7 @@
               </a:defRPr>
             </a:pPr>
             <a:r>
-              <a:t>One ranked list replaces hundreds of uncorrelated alerts. Your SOC analysts investigate the highest-risk entities first, not the loudest alarms.</a:t>
+              <a:t>Confirmed profile matches replace hundreds of uncorrelated alerts. Your SOC analysts investigate real attacker-shaped behavior, not the loudest alarms.</a:t>
             </a:r>
           </a:p>
         </p:txBody>
@@ -8067,7 +8067,7 @@
               </a:defRPr>
             </a:pPr>
             <a:r>
-              <a:t>  8.5% false positive rate with ranked prioritization</a:t>
+              <a:t>  0 false positives on the threat-profile detector</a:t>
             </a:r>
           </a:p>
         </p:txBody>
@@ -8781,7 +8781,7 @@
               </a:defRPr>
             </a:pPr>
             <a:r>
-              <a:t>Composite Scoring detects the anomaly.</a:t>
+              <a:t>The threat-profile detector catches all four.</a:t>
             </a:r>
           </a:p>
         </p:txBody>
@@ -8932,7 +8932,7 @@
               </a:defRPr>
             </a:pPr>
             <a:r>
-              <a:t>8.5%</a:t>
+              <a:t>0%</a:t>
             </a:r>
           </a:p>
         </p:txBody>
@@ -16844,7 +16844,7 @@
               </a:defRPr>
             </a:pPr>
             <a:r>
-              <a:t>250 users monitored over 19 weeks. 4 known attack campaigns embedded in the population.</a:t>
+              <a:t>250 users monitored over 70 weeks. 4 known attack campaigns embedded in the population.</a:t>
             </a:r>
           </a:p>
         </p:txBody>
@@ -17268,7 +17268,7 @@
               </a:defRPr>
             </a:pPr>
             <a:r>
-              <a:t>V-INTELLIGENCE UEBA + COMPOSITE SCORING</a:t>
+              <a:t>V-INTELLIGENCE UEBA + THREAT-PROFILE DETECTOR</a:t>
             </a:r>
           </a:p>
         </p:txBody>
@@ -17304,7 +17304,7 @@
               </a:defRPr>
             </a:pPr>
             <a:r>
-              <a:t>Digital Entity Features → 5-Phase Anomaly Detection</a:t>
+              <a:t>Known-Bad Profile Matching → Multi-Front Detection</a:t>
             </a:r>
           </a:p>
         </p:txBody>
@@ -17412,7 +17412,7 @@
               </a:defRPr>
             </a:pPr>
             <a:r>
-              <a:t>8.5% false positive rate</a:t>
+              <a:t>0 false positives</a:t>
             </a:r>
           </a:p>
         </p:txBody>
@@ -17448,7 +17448,7 @@
               </a:defRPr>
             </a:pPr>
             <a:r>
-              <a:t>All 4 attack types detected — insider, APT, living-off-the-land, telecom intrusion. One ranked list. No threshold tuning. Actionable for SOC analysts.</a:t>
+              <a:t>All 4 attack types detected — insider, APT, living-off-the-land, telecom intrusion. Cohort-relative, label-free profile matching across C2-beacon, DGA-DNS, LOTL-process, cohort-rare access, recon-fanout, and insider-collection fronts.</a:t>
             </a:r>
           </a:p>
         </p:txBody>
@@ -17527,7 +17527,7 @@
               </a:defRPr>
             </a:pPr>
             <a:r>
-              <a:t>Same 250 users. Same 19 weeks. Same telemetry. The difference is what the system understands about behavior.</a:t>
+              <a:t>Same 250 users. Same 70 weeks. Same telemetry. The difference is what the system understands about behavior.</a:t>
             </a:r>
           </a:p>
         </p:txBody>
@@ -18490,7 +18490,7 @@
               </a:defRPr>
             </a:pPr>
             <a:r>
-              <a:t>Rank #24 / 250  •  Score 13.7</a:t>
+              <a:t>Rank below normal  •  Score LOTL-process</a:t>
             </a:r>
           </a:p>
         </p:txBody>
@@ -18543,7 +18543,7 @@
               </a:defRPr>
             </a:pPr>
             <a:r>
-              <a:t>  Breadth + Sustained Deviation</a:t>
+              <a:t>  Threat-Profile: LOTL-process</a:t>
             </a:r>
           </a:p>
         </p:txBody>
@@ -18579,7 +18579,7 @@
               </a:defRPr>
             </a:pPr>
             <a:r>
-              <a:t>Moderate signal strength but anomalous across many features at once. Uses legitimate tools — the anomaly is in the breadth of unusual behavior, not the magnitude of any single action.</a:t>
+              <a:t>Composite ranks USR-042 below the normal population — it does not separate cleanly. The threat-profile detector catches it on the LOTL-process front: legitimate tools used in an attacker-shaped pattern.</a:t>
             </a:r>
           </a:p>
         </p:txBody>
@@ -18775,7 +18775,7 @@
               </a:defRPr>
             </a:pPr>
             <a:r>
-              <a:t>Rank #7 / 250  •  Score 19.4</a:t>
+              <a:t>Rank below normal  •  Score C2-beacon</a:t>
             </a:r>
           </a:p>
         </p:txBody>
@@ -18828,7 +18828,7 @@
               </a:defRPr>
             </a:pPr>
             <a:r>
-              <a:t>  Novelty Persistence</a:t>
+              <a:t>  Threat-Profile: C2-beacon</a:t>
             </a:r>
           </a:p>
         </p:txBody>
@@ -18864,7 +18864,7 @@
               </a:defRPr>
             </a:pPr>
             <a:r>
-              <a:t>Low signal strength. Low breadth. Traditional metrics look completely normal. But new network destinations keep appearing and persisting week after week — the hallmark of C2 beacon infrastructure.</a:t>
+              <a:t>Composite ranks USR-234 below the normal population — novelty alone does not separate it. The threat-profile detector catches it on the C2-beacon front: novel destinations recurring with beacon-like cadence.</a:t>
             </a:r>
           </a:p>
         </p:txBody>

</xml_diff>